<commit_message>
W6 - Weekly report W06; SRS v0.3 in status and conclusion
</commit_message>
<xml_diff>
--- a/weekly-reports/W06/Weekly_Report_W06.pptx
+++ b/weekly-reports/W06/Weekly_Report_W06.pptx
@@ -119,12 +119,12 @@
   <p:extLst>
     <p:ext uri="{521415D9-36F7-43E2-AB2F-B90AF26B5E84}">
       <p14:sectionLst xmlns:p14="http://schemas.microsoft.com/office/powerpoint/2010/main">
-        <p14:section name="Intro" id="{bc13fd6b-e38c-3ea1-86ee-185ec729cf44}">
+        <p14:section name="Intro" id="{71d4574e-5157-52a0-be3c-b8e801286e02}">
           <p14:sldIdLst>
             <p14:sldId id="256"/>
           </p14:sldIdLst>
         </p14:section>
-        <p14:section name="Technical progress" id="{68f9d950-d563-e092-2c2c-15b6f917ed90}">
+        <p14:section name="Technical progress" id="{a184f01f-da5e-5f3b-7ce1-628269ff21e7}">
           <p14:sldIdLst>
             <p14:sldId id="257"/>
             <p14:sldId id="258"/>
@@ -136,18 +136,18 @@
             <p14:sldId id="264"/>
           </p14:sldIdLst>
         </p14:section>
-        <p14:section name="Deliverables" id="{6e68200d-7e23-889f-0b04-1f56f3d1677a}">
+        <p14:section name="Deliverables" id="{a03befef-9ef4-16eb-307a-ea3e24495676}">
           <p14:sldIdLst>
             <p14:sldId id="265"/>
             <p14:sldId id="266"/>
           </p14:sldIdLst>
         </p14:section>
-        <p14:section name="Team" id="{529e536c-bc8f-78bc-60db-7521ae4b5b49}">
+        <p14:section name="Team" id="{661905c8-903a-34fd-631f-8c5020e56fce}">
           <p14:sldIdLst>
             <p14:sldId id="267"/>
           </p14:sldIdLst>
         </p14:section>
-        <p14:section name="Conclusion" id="{8dd76c15-a7d5-728b-243a-3898eb8ee607}">
+        <p14:section name="Conclusion" id="{26427d31-9d6f-1d5a-eed6-a1162f8c6cd5}">
           <p14:sldIdLst>
             <p14:sldId id="268"/>
           </p14:sldIdLst>
@@ -644,7 +644,7 @@
           <a:p>
             <a:r>
               <a:rPr lang="en-US" dirty="0"/>
-              <a:t>Review status: #14 Josué → Haifa (external interfaces), #16 Alfonso → Borja (use case model, fixed in v0.2), #17 Haifa → Avni (glossary), #19 Avni → Alfonso (SRS, fixed in v0.2), #20 and #21 Borja → Yasmine (stakeholders, elicitation plan). Still missing: Yasmine → Josué. Update this column before presenting.</a:t>
+              <a:t>Review status: #14 Josué → Haifa (external interfaces), #16 Alfonso → Borja (use case model, fixed in v0.2), #17 Haifa → Avni (glossary), #19 Avni → Alfonso (SRS, 6 findings, fixed in v0.2 and v0.3), #20 and #21 Borja → Yasmine (stakeholders, elicitation plan). Still missing: Yasmine → Josué. Update this column before presenting.</a:t>
             </a:r>
             <a:endParaRPr lang="en-US" dirty="0"/>
           </a:p>
@@ -3927,7 +3927,7 @@
                             <a:srgbClr val="1F2A30"/>
                           </a:solidFill>
                         </a:rPr>
-                        <a:t>SRS.md (v0.2, review #19 fixed)</a:t>
+                        <a:t>SRS.md (v0.3, review #19 fixed)</a:t>
                       </a:r>
                       <a:endParaRPr lang="en-US" sz="1050" dirty="0"/>
                     </a:p>
@@ -10469,7 +10469,7 @@
                   <a:srgbClr val="DCEBEA"/>
                 </a:solidFill>
               </a:rPr>
-              <a:t>SRS v0.2 with UC1 fully dressed and 51 identified requirements.</a:t>
+              <a:t>SRS v0.3 with UC1 fully dressed and 51 identified requirements.</a:t>
             </a:r>
             <a:endParaRPr lang="en-US" sz="1500" dirty="0"/>
           </a:p>

</xml_diff>